<commit_message>
Measure the first-contact misses: 0 of 1,300 values leaked; blind approval would have exposed 2 columns
- bench/saffron/first_contact_leaks.py: loads a saved first-contact
  registry as it was and queries every missed sensitive column as Support
  and Analyst, as scanned and after blindly accepting every suggested
  PUBLIC. Prints and stores counts only, never values.
- docs/eval/saffron_first_contact.json: SQLite run. As scanned: 0 of 1,300
  raw values returned. Blind approval: accounts.account_no and
  transactions.account_no exposed (200 of 1,300), the case fixed in 93c342f.
- SAFFRON_VALIDATION, deck slide 6 and the prep guide now state the
  measured result and the catch.

Co-Authored-By: Claude Opus 5.5 <noreply@anthropic.com>
Claude-Session: https://claude.ai/code/session_016QoJiCDBgEHu12iXuT5y6c
</commit_message>
<xml_diff>
--- a/docs/MaskGuard_Final_Deck.pptx
+++ b/docs/MaskGuard_Final_Deck.pptx
@@ -118,50 +118,50 @@
   <p:extLst>
     <p:ext uri="{521415D9-36F7-43E2-AB2F-B90AF26B5E84}">
       <p14:sectionLst xmlns:p14="http://schemas.microsoft.com/office/powerpoint/2010/main">
-        <p14:section name="Opening" id="{db0d81ff-e477-5100-ff5e-11baf758107e}">
+        <p14:section name="Opening" id="{c74e0e1d-12fa-35cf-51dc-a7b55a553a42}">
           <p14:sldIdLst>
             <p14:sldId id="256"/>
           </p14:sldIdLst>
         </p14:section>
-        <p14:section name="Problem" id="{68bf7980-b5b0-2dfd-af2e-adc3a86f85fd}">
+        <p14:section name="Problem" id="{ded4ba1c-df37-f746-6ca9-2b51d3cef48b}">
           <p14:sldIdLst>
             <p14:sldId id="257"/>
           </p14:sldIdLst>
         </p14:section>
-        <p14:section name="Solution" id="{d6370bcf-110c-9485-9132-a57e61df0d98}">
+        <p14:section name="Solution" id="{52ead3ce-6a49-9d98-b5eb-872682cb4036}">
           <p14:sldIdLst>
             <p14:sldId id="258"/>
           </p14:sldIdLst>
         </p14:section>
-        <p14:section name="Architecture" id="{21b3b608-98a5-fb9e-976e-ed1866a3ca21}">
+        <p14:section name="Architecture" id="{077bea83-d7dc-ed00-fda3-7492387319d3}">
           <p14:sldIdLst>
             <p14:sldId id="259"/>
           </p14:sldIdLst>
         </p14:section>
-        <p14:section name="Role of AI" id="{e7bbeedd-c636-bf28-8170-587acb00ee32}">
+        <p14:section name="Role of AI" id="{e1c68dad-4dd3-24be-731f-40585763b60d}">
           <p14:sldIdLst>
             <p14:sldId id="260"/>
             <p14:sldId id="261"/>
             <p14:sldId id="262"/>
           </p14:sldIdLst>
         </p14:section>
-        <p14:section name="Demo" id="{d3d35cf8-5f0a-25c0-d89a-ce2c827481f2}">
+        <p14:section name="Demo" id="{88549333-3dcd-9db0-8503-bd4cf71baec3}">
           <p14:sldIdLst>
             <p14:sldId id="263"/>
             <p14:sldId id="264"/>
           </p14:sldIdLst>
         </p14:section>
-        <p14:section name="Proof" id="{094ea535-9a5c-116a-4a8d-7d00db825c95}">
+        <p14:section name="Proof" id="{01c1992f-6e66-3a2d-4c98-ee593112b3bf}">
           <p14:sldIdLst>
             <p14:sldId id="265"/>
           </p14:sldIdLst>
         </p14:section>
-        <p14:section name="Differentiators" id="{d83a569d-10ee-9058-b534-2c401c3b1278}">
+        <p14:section name="Differentiators" id="{6c0182bd-5149-fa2e-f1d2-c89e91640fba}">
           <p14:sldIdLst>
             <p14:sldId id="266"/>
           </p14:sldIdLst>
         </p14:section>
-        <p14:section name="Close" id="{9f75c064-b934-4e61-e99d-65f80f44119b}">
+        <p14:section name="Close" id="{001d4457-ee5d-3c02-bc32-441b34e85ab4}">
           <p14:sldIdLst>
             <p14:sldId id="267"/>
           </p14:sldIdLst>
@@ -1612,7 +1612,7 @@
           <a:p>
             <a:r>
               <a:rPr lang="en-US" dirty="0"/>
-              <a:t>[~1 min · Parameter 3/4: accuracy and baselines] Pre-empt the 'too good to be true' reaction. 'The 0.999 you may have seen is on a public synthetic benchmark — clean data, so treat it as the ceiling. Here is the harder truth. On your Saffron Bank data, the first time we ran it, it found 22 of 35 sensitive columns — F1 0.68. The misses had four causes: money columns with short names like bal and amt, account numbers that looked like plain ids, PANs with 0000 digits that fail the official check, and two address columns. Nothing leaked, because anything the AI isn't sure about stays hidden until a person approves it. We fixed those general causes — not this dataset — and re-ran the benchmark to make sure nothing got worse. Now it finds 35 of 35, with 8 false alarms on the bank's own branch details: F1 0.90.' If asked 'isn't 0.90 tuned to our data?': 'Partly, yes — the fixes were made after seeing it, which is why we show the first-contact number too, and why the safety net doesn't depend on accuracy.' Numbers: docs/SAFFRON_VALIDATION.md and docs/EVALUATION.md.</a:t>
+              <a:t>[~1 min · Parameter 3/4: accuracy and baselines] Pre-empt the 'too good to be true' reaction. 'The 0.999 you may have seen is on a public synthetic benchmark — clean data, so treat it as the ceiling. Here is the harder truth. On your Saffron Bank data, the first time we ran it, it found 22 of 35 sensitive columns — F1 0.68. The misses had four causes: money columns with short names like bal and amt, account numbers that looked like plain ids, PANs with 0000 digits that fail the official check, and two address columns. Nothing leaked — we checked: 0 of 1,300 real values reached Support or Analyst — because anything the AI isn't sure about stays hidden until a person approves it. One honest catch: two account-number columns were wrongly suggested as public; a reviewer who approved every suggestion blindly would have exposed them. That's fixed: a column named like a sensitive kind is never suggested public now. We fixed those general causes — not this dataset — and re-ran the benchmark to make sure nothing got worse. Now it finds 35 of 35, with 8 false alarms on the bank's own branch details: F1 0.90.' If asked 'isn't 0.90 tuned to our data?': 'Partly, yes — the fixes were made after seeing it, which is why we show the first-contact number too, and why the safety net doesn't depend on accuracy.' Numbers: docs/SAFFRON_VALIDATION.md and docs/EVALUATION.md.</a:t>
             </a:r>
             <a:endParaRPr lang="en-US" dirty="0"/>
           </a:p>
@@ -13635,8 +13635,8 @@
         </p:nvSpPr>
         <p:spPr>
           <a:xfrm>
-            <a:off x="7178040" y="4160520"/>
-            <a:ext cx="4434840" cy="548640"/>
+            <a:off x="7178040" y="4114800"/>
+            <a:ext cx="4434840" cy="502920"/>
           </a:xfrm>
           <a:prstGeom prst="rect">
             <a:avLst/>
@@ -13652,7 +13652,7 @@
               <a:buNone/>
             </a:pPr>
             <a:r>
-              <a:rPr lang="en-US" sz="1250" dirty="0">
+              <a:rPr lang="en-US" sz="1200" dirty="0">
                 <a:solidFill>
                   <a:srgbClr val="1E3A5F"/>
                 </a:solidFill>
@@ -13662,7 +13662,7 @@
               </a:rPr>
               <a:t>+ 8 false alarms: the bank's own branch phone, email, address and IFSC. Masked, not leaked; approved in one step.</a:t>
             </a:r>
-            <a:endParaRPr lang="en-US" sz="1250" dirty="0"/>
+            <a:endParaRPr lang="en-US" sz="1200" dirty="0"/>
           </a:p>
         </p:txBody>
       </p:sp>
@@ -13674,12 +13674,12 @@
         </p:nvSpPr>
         <p:spPr>
           <a:xfrm>
-            <a:off x="7178040" y="4800600"/>
-            <a:ext cx="4434840" cy="1417320"/>
+            <a:off x="7178040" y="4617720"/>
+            <a:ext cx="4434840" cy="1645920"/>
           </a:xfrm>
           <a:prstGeom prst="roundRect">
             <a:avLst>
-              <a:gd name="adj" fmla="val 5161"/>
+              <a:gd name="adj" fmla="val 4444"/>
             </a:avLst>
           </a:prstGeom>
           <a:solidFill>
@@ -13701,7 +13701,7 @@
         </p:nvSpPr>
         <p:spPr>
           <a:xfrm>
-            <a:off x="7360920" y="4983480"/>
+            <a:off x="7360920" y="4773168"/>
             <a:ext cx="566928" cy="566928"/>
           </a:xfrm>
           <a:prstGeom prst="ellipse">
@@ -13734,7 +13734,7 @@
         </p:blipFill>
         <p:spPr>
           <a:xfrm>
-            <a:off x="7502652" y="5125212"/>
+            <a:off x="7502652" y="4914900"/>
             <a:ext cx="283464" cy="283464"/>
           </a:xfrm>
           <a:prstGeom prst="rect">
@@ -13750,8 +13750,8 @@
         </p:nvSpPr>
         <p:spPr>
           <a:xfrm>
-            <a:off x="8046720" y="4937760"/>
-            <a:ext cx="3474720" cy="411480"/>
+            <a:off x="8046720" y="4727448"/>
+            <a:ext cx="3474720" cy="365760"/>
           </a:xfrm>
           <a:prstGeom prst="rect">
             <a:avLst/>
@@ -13789,8 +13789,8 @@
         </p:nvSpPr>
         <p:spPr>
           <a:xfrm>
-            <a:off x="8046720" y="5349240"/>
-            <a:ext cx="3429000" cy="822960"/>
+            <a:off x="8046720" y="5102352"/>
+            <a:ext cx="3429000" cy="1115568"/>
           </a:xfrm>
           <a:prstGeom prst="rect">
             <a:avLst/>
@@ -13803,10 +13803,13 @@
           <a:lstStyle/>
           <a:p>
             <a:pPr indent="0" marL="0">
-              <a:buNone/>
-            </a:pPr>
-            <a:r>
-              <a:rPr lang="en-US" sz="1200" dirty="0">
+              <a:spcAft>
+                <a:spcPts val="300"/>
+              </a:spcAft>
+              <a:buNone/>
+            </a:pPr>
+            <a:r>
+              <a:rPr lang="en-US" sz="1150" dirty="0">
                 <a:solidFill>
                   <a:srgbClr val="CBD5E1"/>
                 </a:solidFill>
@@ -13814,9 +13817,29 @@
                 <a:ea typeface="Calibri" pitchFamily="34" charset="-122"/>
                 <a:cs typeface="Calibri" pitchFamily="34" charset="-120"/>
               </a:rPr>
-              <a:t>Anything the AI is unsure about stays hidden until a person approves it. We fixed the general causes, then re-checked the benchmark did not get worse.</a:t>
-            </a:r>
-            <a:endParaRPr lang="en-US" sz="1200" dirty="0"/>
+              <a:t>Checked: 0 of 1,300 real values reached Support or Analyst. Unsure columns stay hidden until a person approves them.</a:t>
+            </a:r>
+            <a:endParaRPr lang="en-US" sz="1150" dirty="0"/>
+          </a:p>
+          <a:p>
+            <a:pPr indent="0" marL="0">
+              <a:spcAft>
+                <a:spcPts val="300"/>
+              </a:spcAft>
+              <a:buNone/>
+            </a:pPr>
+            <a:r>
+              <a:rPr lang="en-US" sz="1150" dirty="0">
+                <a:solidFill>
+                  <a:srgbClr val="D97706"/>
+                </a:solidFill>
+                <a:latin typeface="Calibri" pitchFamily="34" charset="0"/>
+                <a:ea typeface="Calibri" pitchFamily="34" charset="-122"/>
+                <a:cs typeface="Calibri" pitchFamily="34" charset="-120"/>
+              </a:rPr>
+              <a:t>One catch: 2 account-number columns were wrongly suggested as public; approving that blindly would have exposed them. Fixed.</a:t>
+            </a:r>
+            <a:endParaRPr lang="en-US" sz="1150" dirty="0"/>
           </a:p>
         </p:txBody>
       </p:sp>

</xml_diff>